<commit_message>
added boy girl paradox
</commit_message>
<xml_diff>
--- a/statistics_01_probability.pptx
+++ b/statistics_01_probability.pptx
@@ -5,7 +5,7 @@
     <p:sldMasterId id="2147483659" r:id="rId1"/>
   </p:sldMasterIdLst>
   <p:notesMasterIdLst>
-    <p:notesMasterId r:id="rId10"/>
+    <p:notesMasterId r:id="rId11"/>
   </p:notesMasterIdLst>
   <p:sldIdLst>
     <p:sldId id="262" r:id="rId2"/>
@@ -15,7 +15,8 @@
     <p:sldId id="274" r:id="rId6"/>
     <p:sldId id="292" r:id="rId7"/>
     <p:sldId id="290" r:id="rId8"/>
-    <p:sldId id="265" r:id="rId9"/>
+    <p:sldId id="293" r:id="rId9"/>
+    <p:sldId id="265" r:id="rId10"/>
   </p:sldIdLst>
   <p:sldSz cx="12192000" cy="6858000"/>
   <p:notesSz cx="6858000" cy="9144000"/>
@@ -18212,6 +18213,522 @@
           <p:cNvPr id="4" name="TextBox 3">
             <a:extLst>
               <a:ext uri="{FF2B5EF4-FFF2-40B4-BE49-F238E27FC236}">
+                <a16:creationId xmlns:a16="http://schemas.microsoft.com/office/drawing/2014/main" id="{929F7588-E09F-B248-9AF8-0614D59D3E5A}"/>
+              </a:ext>
+            </a:extLst>
+          </p:cNvPr>
+          <p:cNvSpPr txBox="1"/>
+          <p:nvPr/>
+        </p:nvSpPr>
+        <p:spPr>
+          <a:xfrm>
+            <a:off x="0" y="0"/>
+            <a:ext cx="7010400" cy="738664"/>
+          </a:xfrm>
+          <a:prstGeom prst="rect">
+            <a:avLst/>
+          </a:prstGeom>
+          <a:noFill/>
+        </p:spPr>
+        <p:txBody>
+          <a:bodyPr wrap="square" rtlCol="0">
+            <a:spAutoFit/>
+          </a:bodyPr>
+          <a:lstStyle/>
+          <a:p>
+            <a:r>
+              <a:rPr lang="en-US" sz="2800" b="1" dirty="0"/>
+              <a:t>Boy or Girl Paradox</a:t>
+            </a:r>
+          </a:p>
+          <a:p>
+            <a:r>
+              <a:rPr lang="en-US" b="1" dirty="0"/>
+              <a:t>(a.k.a. "The Two Child Problem", "Mr. Smith's Children", "Mrs. Smith Problem").</a:t>
+            </a:r>
+          </a:p>
+        </p:txBody>
+      </p:sp>
+      <p:sp>
+        <p:nvSpPr>
+          <p:cNvPr id="5" name="TextBox 4">
+            <a:extLst>
+              <a:ext uri="{FF2B5EF4-FFF2-40B4-BE49-F238E27FC236}">
+                <a16:creationId xmlns:a16="http://schemas.microsoft.com/office/drawing/2014/main" id="{6C2F706E-77C7-AF44-9FCC-6397C644CBC6}"/>
+              </a:ext>
+            </a:extLst>
+          </p:cNvPr>
+          <p:cNvSpPr txBox="1"/>
+          <p:nvPr/>
+        </p:nvSpPr>
+        <p:spPr>
+          <a:xfrm>
+            <a:off x="0" y="1341119"/>
+            <a:ext cx="5413248" cy="5047536"/>
+          </a:xfrm>
+          <a:prstGeom prst="rect">
+            <a:avLst/>
+          </a:prstGeom>
+          <a:noFill/>
+        </p:spPr>
+        <p:txBody>
+          <a:bodyPr wrap="square" rtlCol="0">
+            <a:spAutoFit/>
+          </a:bodyPr>
+          <a:lstStyle/>
+          <a:p>
+            <a:r>
+              <a:rPr lang="en-US" dirty="0"/>
+              <a:t>Initially formulated at 1959, when Martin Gardner featured it in his October 1959 "Mathematical Games column" in Scientific American. He titled it The Two Children Problem, and phrased the paradox as follows:</a:t>
+            </a:r>
+          </a:p>
+          <a:p>
+            <a:endParaRPr lang="en-US" dirty="0"/>
+          </a:p>
+          <a:p>
+            <a:r>
+              <a:rPr lang="en-US" dirty="0"/>
+              <a:t>Question 1: Mr. Jones has two children. The older child is a girl. What is the probability that both children are girls?</a:t>
+            </a:r>
+          </a:p>
+          <a:p>
+            <a:endParaRPr lang="en-US" dirty="0"/>
+          </a:p>
+          <a:p>
+            <a:endParaRPr lang="en-US" dirty="0"/>
+          </a:p>
+          <a:p>
+            <a:endParaRPr lang="en-US" dirty="0"/>
+          </a:p>
+          <a:p>
+            <a:r>
+              <a:rPr lang="en-US" dirty="0"/>
+              <a:t>Question 2: Mr. Smith has two children. At least one of them is a boy. What is the probability that both children are boys?</a:t>
+            </a:r>
+          </a:p>
+          <a:p>
+            <a:endParaRPr lang="en-US" dirty="0"/>
+          </a:p>
+          <a:p>
+            <a:endParaRPr lang="en-US" dirty="0"/>
+          </a:p>
+          <a:p>
+            <a:r>
+              <a:rPr lang="en-US" dirty="0"/>
+              <a:t> - </a:t>
+            </a:r>
+            <a:r>
+              <a:rPr lang="en-US" dirty="0">
+                <a:hlinkClick r:id="rId2"/>
+              </a:rPr>
+              <a:t>https://en.wikipedia.org/wiki/Boy_or_Girl_paradox</a:t>
+            </a:r>
+            <a:r>
+              <a:rPr lang="en-US" dirty="0"/>
+              <a:t> </a:t>
+            </a:r>
+          </a:p>
+          <a:p>
+            <a:endParaRPr lang="en-US" dirty="0"/>
+          </a:p>
+          <a:p>
+            <a:endParaRPr lang="en-US" dirty="0"/>
+          </a:p>
+          <a:p>
+            <a:r>
+              <a:rPr lang="en-US" dirty="0"/>
+              <a:t>video - This May Be The Most Counterintuitive Probability Paradox I've Ever Seen | Can you spot the error?</a:t>
+            </a:r>
+          </a:p>
+          <a:p>
+            <a:r>
+              <a:rPr lang="en-US" dirty="0"/>
+              <a:t>- </a:t>
+            </a:r>
+            <a:r>
+              <a:rPr lang="en-US" dirty="0">
+                <a:hlinkClick r:id="rId3"/>
+              </a:rPr>
+              <a:t>https://www.youtube.com/watch?v=bDZieLmya_I</a:t>
+            </a:r>
+            <a:endParaRPr lang="en-US" dirty="0"/>
+          </a:p>
+          <a:p>
+            <a:endParaRPr lang="en-US" dirty="0"/>
+          </a:p>
+          <a:p>
+            <a:r>
+              <a:rPr lang="en-US" dirty="0"/>
+              <a:t>video - The Boy or Girl Probability Paradox Resolved</a:t>
+            </a:r>
+          </a:p>
+          <a:p>
+            <a:r>
+              <a:rPr lang="en-US" dirty="0"/>
+              <a:t>- </a:t>
+            </a:r>
+            <a:r>
+              <a:rPr lang="en-US" dirty="0">
+                <a:hlinkClick r:id="rId4"/>
+              </a:rPr>
+              <a:t>https://www.youtube.com/watch?v=ElB350w8iJo</a:t>
+            </a:r>
+            <a:r>
+              <a:rPr lang="en-US" dirty="0"/>
+              <a:t> </a:t>
+            </a:r>
+          </a:p>
+        </p:txBody>
+      </p:sp>
+      <p:pic>
+        <p:nvPicPr>
+          <p:cNvPr id="6" name="Picture 5">
+            <a:extLst>
+              <a:ext uri="{FF2B5EF4-FFF2-40B4-BE49-F238E27FC236}">
+                <a16:creationId xmlns:a16="http://schemas.microsoft.com/office/drawing/2014/main" id="{CE8981C4-01EB-C345-AB38-EA6A36D18AD5}"/>
+              </a:ext>
+            </a:extLst>
+          </p:cNvPr>
+          <p:cNvPicPr>
+            <a:picLocks noChangeAspect="1"/>
+          </p:cNvPicPr>
+          <p:nvPr/>
+        </p:nvPicPr>
+        <p:blipFill>
+          <a:blip r:embed="rId5" cstate="email">
+            <a:extLst>
+              <a:ext uri="{28A0092B-C50C-407E-A947-70E740481C1C}">
+                <a14:useLocalDpi xmlns:a14="http://schemas.microsoft.com/office/drawing/2010/main"/>
+              </a:ext>
+            </a:extLst>
+          </a:blip>
+          <a:stretch>
+            <a:fillRect/>
+          </a:stretch>
+        </p:blipFill>
+        <p:spPr>
+          <a:xfrm>
+            <a:off x="8618118" y="1019080"/>
+            <a:ext cx="1896973" cy="1431512"/>
+          </a:xfrm>
+          <a:prstGeom prst="rect">
+            <a:avLst/>
+          </a:prstGeom>
+        </p:spPr>
+      </p:pic>
+      <p:pic>
+        <p:nvPicPr>
+          <p:cNvPr id="7" name="Picture 6">
+            <a:extLst>
+              <a:ext uri="{FF2B5EF4-FFF2-40B4-BE49-F238E27FC236}">
+                <a16:creationId xmlns:a16="http://schemas.microsoft.com/office/drawing/2014/main" id="{CA566D42-48FC-5349-A28F-E08379F94264}"/>
+              </a:ext>
+            </a:extLst>
+          </p:cNvPr>
+          <p:cNvPicPr>
+            <a:picLocks noChangeAspect="1"/>
+          </p:cNvPicPr>
+          <p:nvPr/>
+        </p:nvPicPr>
+        <p:blipFill>
+          <a:blip r:embed="rId6" cstate="email">
+            <a:extLst>
+              <a:ext uri="{28A0092B-C50C-407E-A947-70E740481C1C}">
+                <a14:useLocalDpi xmlns:a14="http://schemas.microsoft.com/office/drawing/2010/main"/>
+              </a:ext>
+            </a:extLst>
+          </a:blip>
+          <a:stretch>
+            <a:fillRect/>
+          </a:stretch>
+        </p:blipFill>
+        <p:spPr>
+          <a:xfrm>
+            <a:off x="8618118" y="3154862"/>
+            <a:ext cx="1659816" cy="1252547"/>
+          </a:xfrm>
+          <a:prstGeom prst="rect">
+            <a:avLst/>
+          </a:prstGeom>
+        </p:spPr>
+      </p:pic>
+      <p:pic>
+        <p:nvPicPr>
+          <p:cNvPr id="8" name="Picture 7">
+            <a:extLst>
+              <a:ext uri="{FF2B5EF4-FFF2-40B4-BE49-F238E27FC236}">
+                <a16:creationId xmlns:a16="http://schemas.microsoft.com/office/drawing/2014/main" id="{F6EBFE19-F7F6-8D45-95F9-7186733F377F}"/>
+              </a:ext>
+            </a:extLst>
+          </p:cNvPr>
+          <p:cNvPicPr>
+            <a:picLocks noChangeAspect="1"/>
+          </p:cNvPicPr>
+          <p:nvPr/>
+        </p:nvPicPr>
+        <p:blipFill>
+          <a:blip r:embed="rId7" cstate="email">
+            <a:extLst>
+              <a:ext uri="{28A0092B-C50C-407E-A947-70E740481C1C}">
+                <a14:useLocalDpi xmlns:a14="http://schemas.microsoft.com/office/drawing/2010/main"/>
+              </a:ext>
+            </a:extLst>
+          </a:blip>
+          <a:stretch>
+            <a:fillRect/>
+          </a:stretch>
+        </p:blipFill>
+        <p:spPr>
+          <a:xfrm>
+            <a:off x="6888073" y="4407409"/>
+            <a:ext cx="5219700" cy="1662181"/>
+          </a:xfrm>
+          <a:prstGeom prst="rect">
+            <a:avLst/>
+          </a:prstGeom>
+        </p:spPr>
+      </p:pic>
+      <p:pic>
+        <p:nvPicPr>
+          <p:cNvPr id="9" name="Picture 8">
+            <a:extLst>
+              <a:ext uri="{FF2B5EF4-FFF2-40B4-BE49-F238E27FC236}">
+                <a16:creationId xmlns:a16="http://schemas.microsoft.com/office/drawing/2014/main" id="{7F216E6E-201A-AE49-8004-C7E4DB60139B}"/>
+              </a:ext>
+            </a:extLst>
+          </p:cNvPr>
+          <p:cNvPicPr>
+            <a:picLocks noChangeAspect="1"/>
+          </p:cNvPicPr>
+          <p:nvPr/>
+        </p:nvPicPr>
+        <p:blipFill>
+          <a:blip r:embed="rId8" cstate="email">
+            <a:extLst>
+              <a:ext uri="{28A0092B-C50C-407E-A947-70E740481C1C}">
+                <a14:useLocalDpi xmlns:a14="http://schemas.microsoft.com/office/drawing/2010/main"/>
+              </a:ext>
+            </a:extLst>
+          </a:blip>
+          <a:stretch>
+            <a:fillRect/>
+          </a:stretch>
+        </p:blipFill>
+        <p:spPr>
+          <a:xfrm>
+            <a:off x="6982533" y="6233057"/>
+            <a:ext cx="3076149" cy="590550"/>
+          </a:xfrm>
+          <a:prstGeom prst="rect">
+            <a:avLst/>
+          </a:prstGeom>
+        </p:spPr>
+      </p:pic>
+      <p:sp>
+        <p:nvSpPr>
+          <p:cNvPr id="10" name="TextBox 9">
+            <a:extLst>
+              <a:ext uri="{FF2B5EF4-FFF2-40B4-BE49-F238E27FC236}">
+                <a16:creationId xmlns:a16="http://schemas.microsoft.com/office/drawing/2014/main" id="{6515EADD-2F8D-4D47-B4FB-237457FCE401}"/>
+              </a:ext>
+            </a:extLst>
+          </p:cNvPr>
+          <p:cNvSpPr txBox="1"/>
+          <p:nvPr/>
+        </p:nvSpPr>
+        <p:spPr>
+          <a:xfrm>
+            <a:off x="7378700" y="1492681"/>
+            <a:ext cx="838200" cy="307777"/>
+          </a:xfrm>
+          <a:prstGeom prst="rect">
+            <a:avLst/>
+          </a:prstGeom>
+          <a:noFill/>
+        </p:spPr>
+        <p:txBody>
+          <a:bodyPr wrap="square" rtlCol="0">
+            <a:spAutoFit/>
+          </a:bodyPr>
+          <a:lstStyle/>
+          <a:p>
+            <a:r>
+              <a:rPr lang="en-US" b="1" dirty="0">
+                <a:solidFill>
+                  <a:srgbClr val="FF0000"/>
+                </a:solidFill>
+              </a:rPr>
+              <a:t>P = 1/2</a:t>
+            </a:r>
+          </a:p>
+        </p:txBody>
+      </p:sp>
+      <p:sp>
+        <p:nvSpPr>
+          <p:cNvPr id="11" name="TextBox 10">
+            <a:extLst>
+              <a:ext uri="{FF2B5EF4-FFF2-40B4-BE49-F238E27FC236}">
+                <a16:creationId xmlns:a16="http://schemas.microsoft.com/office/drawing/2014/main" id="{7FE20994-BE99-4142-BFCB-6E614279346F}"/>
+              </a:ext>
+            </a:extLst>
+          </p:cNvPr>
+          <p:cNvSpPr txBox="1"/>
+          <p:nvPr/>
+        </p:nvSpPr>
+        <p:spPr>
+          <a:xfrm>
+            <a:off x="7378700" y="3603386"/>
+            <a:ext cx="838200" cy="307777"/>
+          </a:xfrm>
+          <a:prstGeom prst="rect">
+            <a:avLst/>
+          </a:prstGeom>
+          <a:noFill/>
+        </p:spPr>
+        <p:txBody>
+          <a:bodyPr wrap="square" rtlCol="0">
+            <a:spAutoFit/>
+          </a:bodyPr>
+          <a:lstStyle/>
+          <a:p>
+            <a:r>
+              <a:rPr lang="en-US" b="1" dirty="0">
+                <a:solidFill>
+                  <a:srgbClr val="FF0000"/>
+                </a:solidFill>
+              </a:rPr>
+              <a:t>P = 1/3</a:t>
+            </a:r>
+          </a:p>
+        </p:txBody>
+      </p:sp>
+      <p:sp>
+        <p:nvSpPr>
+          <p:cNvPr id="14" name="Right Arrow 13">
+            <a:extLst>
+              <a:ext uri="{FF2B5EF4-FFF2-40B4-BE49-F238E27FC236}">
+                <a16:creationId xmlns:a16="http://schemas.microsoft.com/office/drawing/2014/main" id="{FD13A09C-709B-8A40-A89E-21595B6F32E2}"/>
+              </a:ext>
+            </a:extLst>
+          </p:cNvPr>
+          <p:cNvSpPr/>
+          <p:nvPr/>
+        </p:nvSpPr>
+        <p:spPr>
+          <a:xfrm rot="966397">
+            <a:off x="5705856" y="3835034"/>
+            <a:ext cx="914400" cy="307777"/>
+          </a:xfrm>
+          <a:prstGeom prst="rightArrow">
+            <a:avLst/>
+          </a:prstGeom>
+        </p:spPr>
+        <p:style>
+          <a:lnRef idx="2">
+            <a:schemeClr val="accent1">
+              <a:shade val="50000"/>
+            </a:schemeClr>
+          </a:lnRef>
+          <a:fillRef idx="1">
+            <a:schemeClr val="accent1"/>
+          </a:fillRef>
+          <a:effectRef idx="0">
+            <a:schemeClr val="accent1"/>
+          </a:effectRef>
+          <a:fontRef idx="minor">
+            <a:schemeClr val="lt1"/>
+          </a:fontRef>
+        </p:style>
+        <p:txBody>
+          <a:bodyPr rtlCol="0" anchor="ctr"/>
+          <a:lstStyle/>
+          <a:p>
+            <a:pPr algn="ctr"/>
+            <a:endParaRPr lang="en-US"/>
+          </a:p>
+        </p:txBody>
+      </p:sp>
+      <p:sp>
+        <p:nvSpPr>
+          <p:cNvPr id="15" name="Right Arrow 14">
+            <a:extLst>
+              <a:ext uri="{FF2B5EF4-FFF2-40B4-BE49-F238E27FC236}">
+                <a16:creationId xmlns:a16="http://schemas.microsoft.com/office/drawing/2014/main" id="{A5361324-BBC4-5342-9E8F-153114277AB2}"/>
+              </a:ext>
+            </a:extLst>
+          </p:cNvPr>
+          <p:cNvSpPr/>
+          <p:nvPr/>
+        </p:nvSpPr>
+        <p:spPr>
+          <a:xfrm rot="20081528">
+            <a:off x="5758979" y="2104279"/>
+            <a:ext cx="914400" cy="307777"/>
+          </a:xfrm>
+          <a:prstGeom prst="rightArrow">
+            <a:avLst/>
+          </a:prstGeom>
+        </p:spPr>
+        <p:style>
+          <a:lnRef idx="2">
+            <a:schemeClr val="accent1">
+              <a:shade val="50000"/>
+            </a:schemeClr>
+          </a:lnRef>
+          <a:fillRef idx="1">
+            <a:schemeClr val="accent1"/>
+          </a:fillRef>
+          <a:effectRef idx="0">
+            <a:schemeClr val="accent1"/>
+          </a:effectRef>
+          <a:fontRef idx="minor">
+            <a:schemeClr val="lt1"/>
+          </a:fontRef>
+        </p:style>
+        <p:txBody>
+          <a:bodyPr rtlCol="0" anchor="ctr"/>
+          <a:lstStyle/>
+          <a:p>
+            <a:pPr algn="ctr"/>
+            <a:endParaRPr lang="en-US"/>
+          </a:p>
+        </p:txBody>
+      </p:sp>
+    </p:spTree>
+    <p:extLst>
+      <p:ext uri="{BB962C8B-B14F-4D97-AF65-F5344CB8AC3E}">
+        <p14:creationId xmlns:p14="http://schemas.microsoft.com/office/powerpoint/2010/main" val="3145259505"/>
+      </p:ext>
+    </p:extLst>
+  </p:cSld>
+  <p:clrMapOvr>
+    <a:masterClrMapping/>
+  </p:clrMapOvr>
+</p:sld>
+</file>
+
+<file path=ppt/slides/slide9.xml><?xml version="1.0" encoding="utf-8"?>
+<p:sld xmlns:a="http://schemas.openxmlformats.org/drawingml/2006/main" xmlns:r="http://schemas.openxmlformats.org/officeDocument/2006/relationships" xmlns:p="http://schemas.openxmlformats.org/presentationml/2006/main">
+  <p:cSld>
+    <p:spTree>
+      <p:nvGrpSpPr>
+        <p:cNvPr id="1" name=""/>
+        <p:cNvGrpSpPr/>
+        <p:nvPr/>
+      </p:nvGrpSpPr>
+      <p:grpSpPr>
+        <a:xfrm>
+          <a:off x="0" y="0"/>
+          <a:ext cx="0" cy="0"/>
+          <a:chOff x="0" y="0"/>
+          <a:chExt cx="0" cy="0"/>
+        </a:xfrm>
+      </p:grpSpPr>
+      <p:sp>
+        <p:nvSpPr>
+          <p:cNvPr id="4" name="TextBox 3">
+            <a:extLst>
+              <a:ext uri="{FF2B5EF4-FFF2-40B4-BE49-F238E27FC236}">
                 <a16:creationId xmlns:a16="http://schemas.microsoft.com/office/drawing/2014/main" id="{1EB5F268-965F-C142-A102-83C02389B555}"/>
               </a:ext>
             </a:extLst>

</xml_diff>